<commit_message>
chore: remove outdated Suri product requirements document
</commit_message>
<xml_diff>
--- a/docs/Team ServerMaya Submission _ AI Builder Cup.pptx
+++ b/docs/Team ServerMaya Submission _ AI Builder Cup.pptx
@@ -17499,13 +17499,7 @@
             </a:endParaRPr>
           </a:p>
           <a:p>
-            <a:pPr marL="457200" lvl="0" indent="-317500" algn="l" rtl="0">
-              <a:spcBef>
-                <a:spcPts val="0"/>
-              </a:spcBef>
-              <a:spcAft>
-                <a:spcPts val="0"/>
-              </a:spcAft>
+            <a:pPr marL="457200" lvl="0" indent="-317500">
               <a:buSzPts val="1400"/>
               <a:buFont typeface="Google Sans Flex Medium"/>
               <a:buChar char="●"/>
@@ -17517,7 +17511,43 @@
                 <a:cs typeface="Google Sans Flex Medium"/>
                 <a:sym typeface="Google Sans Flex Medium"/>
               </a:rPr>
-              <a:t>Demo Video Link (3 Minutes)</a:t>
+              <a:t>Demo Video Link (3 Minutes) - https://</a:t>
+            </a:r>
+            <a:r>
+              <a:rPr lang="en-GB" dirty="0" err="1">
+                <a:latin typeface="Google Sans Flex Medium"/>
+                <a:ea typeface="Google Sans Flex Medium"/>
+                <a:cs typeface="Google Sans Flex Medium"/>
+                <a:sym typeface="Google Sans Flex Medium"/>
+              </a:rPr>
+              <a:t>www.youtube.com</a:t>
+            </a:r>
+            <a:r>
+              <a:rPr lang="en-GB" dirty="0">
+                <a:latin typeface="Google Sans Flex Medium"/>
+                <a:ea typeface="Google Sans Flex Medium"/>
+                <a:cs typeface="Google Sans Flex Medium"/>
+                <a:sym typeface="Google Sans Flex Medium"/>
+              </a:rPr>
+              <a:t>/</a:t>
+            </a:r>
+            <a:r>
+              <a:rPr lang="en-GB" dirty="0" err="1">
+                <a:latin typeface="Google Sans Flex Medium"/>
+                <a:ea typeface="Google Sans Flex Medium"/>
+                <a:cs typeface="Google Sans Flex Medium"/>
+                <a:sym typeface="Google Sans Flex Medium"/>
+              </a:rPr>
+              <a:t>watch?v</a:t>
+            </a:r>
+            <a:r>
+              <a:rPr lang="en-GB">
+                <a:latin typeface="Google Sans Flex Medium"/>
+                <a:ea typeface="Google Sans Flex Medium"/>
+                <a:cs typeface="Google Sans Flex Medium"/>
+                <a:sym typeface="Google Sans Flex Medium"/>
+              </a:rPr>
+              <a:t>=MD8shu3V4QA</a:t>
             </a:r>
             <a:endParaRPr dirty="0">
               <a:latin typeface="Google Sans Flex Medium"/>

</xml_diff>